<commit_message>
Bande-annonce de 60 s et contenus adaptés aux adultes
Remplace la vidéo longue par une bande-annonce de 58,8 s au style futuriste
humain × IA, sans narration, sur une trame électro synthétisée.
Zine et présentation adaptés aux adultes volontaires de tout acabit :
exemples tirés du travail et de la famille, règle du joker, diapo
« Les coups bas dans la vraie vie » à la place du lien avec le programme scolaire.

Co-Authored-By: Claude Opus 5.5 <noreply@anthropic.com>
Claude-Session: https://claude.ai/code/session_01CA8BLVt7gkumiP2uBqg34x
</commit_message>
<xml_diff>
--- a/debat-agreable/seminaire-confrontation-agreable.pptx
+++ b/debat-agreable/seminaire-confrontation-agreable.pptx
@@ -138,14 +138,14 @@
   <p:extLst>
     <p:ext uri="{521415D9-36F7-43E2-AB2F-B90AF26B5E84}">
       <p14:sectionLst xmlns:p14="http://schemas.microsoft.com/office/powerpoint/2010/main">
-        <p14:section name="Ouverture" id="{7d39e4c0-30ca-ea2d-d830-d2756a3d1d7a}">
+        <p14:section name="Ouverture" id="{c532cc7e-cbbe-2c01-b8ad-a4f5a158b6c9}">
           <p14:sldIdLst>
             <p14:sldId id="256"/>
             <p14:sldId id="257"/>
             <p14:sldId id="258"/>
           </p14:sldIdLst>
         </p14:section>
-        <p14:section name="Échauffement" id="{940d81d9-f88f-41d5-66c9-05fc1fcc6ff6}">
+        <p14:section name="Échauffement" id="{5247a460-a520-0874-bb39-85f4c0280087}">
           <p14:sldIdLst>
             <p14:sldId id="259"/>
             <p14:sldId id="260"/>
@@ -153,7 +153,7 @@
             <p14:sldId id="262"/>
           </p14:sldIdLst>
         </p14:section>
-        <p14:section name="Le manuel du tricheur" id="{4cfa5b7e-596b-116f-1a88-9001ff08b7af}">
+        <p14:section name="Le manuel du tricheur" id="{087c79b5-bb2c-d709-c17d-aa934c1b0316}">
           <p14:sldIdLst>
             <p14:sldId id="263"/>
             <p14:sldId id="264"/>
@@ -164,7 +164,7 @@
             <p14:sldId id="269"/>
           </p14:sldIdLst>
         </p14:section>
-        <p14:section name="Le bestiaire" id="{99bfdff9-fa93-ae95-8d1d-5813b4c4d9b2}">
+        <p14:section name="Le bestiaire" id="{af62c3d9-4985-51c9-0aba-0bd58433ce26}">
           <p14:sldIdLst>
             <p14:sldId id="270"/>
             <p14:sldId id="271"/>
@@ -177,7 +177,7 @@
             <p14:sldId id="278"/>
           </p14:sldIdLst>
         </p14:section>
-        <p14:section name="Ateliers d'écriture" id="{915811bc-e1d6-d426-a332-c2ce073be076}">
+        <p14:section name="Ateliers d'écriture" id="{d767f0f5-3d20-9001-42d1-3add359cf0f5}">
           <p14:sldIdLst>
             <p14:sldId id="279"/>
             <p14:sldId id="280"/>
@@ -185,14 +185,14 @@
             <p14:sldId id="282"/>
           </p14:sldIdLst>
         </p14:section>
-        <p14:section name="L'arène agréable" id="{c9145d6f-53ca-da00-0f57-107ab1d0f624}">
+        <p14:section name="L'arène agréable" id="{6377adf2-8935-22a6-f528-faa2b65afe03}">
           <p14:sldIdLst>
             <p14:sldId id="283"/>
             <p14:sldId id="284"/>
             <p14:sldId id="285"/>
           </p14:sldIdLst>
         </p14:section>
-        <p14:section name="Sortie" id="{eb9af4a0-e897-bce0-158b-02c02dfdfbf0}">
+        <p14:section name="Sortie" id="{4df5c2d4-ae5e-d9c1-6b52-3c2a4d844a82}">
           <p14:sldIdLst>
             <p14:sldId id="286"/>
             <p14:sldId id="287"/>
@@ -778,7 +778,7 @@
           <a:p>
             <a:r>
               <a:rPr lang="en-US" dirty="0"/>
-              <a:t>Les numéros correspondent aux stratagèmes de Schopenhauer. Les surnoms sont les nôtres, pour que les élèves les retiennent. Ces 9 cartes deviennent la grille de bingo de l'activité du bestiaire.</a:t>
+              <a:t>Les numéros correspondent aux stratagèmes de Schopenhauer. Les surnoms sont les nôtres, pour qu'on les retienne. Ces 9 cartes deviennent la grille de bingo de l'activité du bestiaire.</a:t>
             </a:r>
             <a:endParaRPr lang="en-US" dirty="0"/>
           </a:p>
@@ -866,7 +866,7 @@
           <a:p>
             <a:r>
               <a:rPr lang="en-US" dirty="0"/>
-              <a:t>Valider la liste exacte des procédés avec la version en vigueur du programme CCQ de votre cycle. Aussi en lien : Français, communiquer oralement (argumenter, adapter son discours).</a:t>
+              <a:t>Demander aux participants de compléter le tableau avec leurs propres exemples, anonymisés. Où les entendez-vous le plus? Lesquels utilisez-vous vous-même sans vous en rendre compte?</a:t>
             </a:r>
             <a:endParaRPr lang="en-US" dirty="0"/>
           </a:p>
@@ -2098,7 +2098,7 @@
           <a:p>
             <a:r>
               <a:rPr lang="en-US" dirty="0"/>
-              <a:t>Utiliser la page 5 du zine. Lecture à voix haute : faire sentir physiquement la différence de ton. Variante numérique : réécrire un commentaire de réseau social fictif.</a:t>
+              <a:t>Utiliser la page 5 du zine. Lecture à voix haute : faire sentir physiquement la différence de ton. Variante : réécrire un commentaire de réseau social fictif.</a:t>
             </a:r>
             <a:endParaRPr lang="en-US" dirty="0"/>
           </a:p>
@@ -2274,7 +2274,7 @@
           <a:p>
             <a:r>
               <a:rPr lang="en-US" dirty="0"/>
-              <a:t>Production finale du séminaire. On compile les stratagèmes de la classe dans un « Manuel du débat loyal » numéroté à partir de 39 : le zine nº 2 de la classe. Page 7 du zine.</a:t>
+              <a:t>Production finale du séminaire. On compile les stratagèmes du groupe dans un « Manuel du débat loyal » numéroté à partir de 39 : le zine nº 2 du groupe. Page 7 du zine.</a:t>
             </a:r>
             <a:endParaRPr lang="en-US" dirty="0"/>
           </a:p>
@@ -2538,7 +2538,7 @@
           <a:p>
             <a:r>
               <a:rPr lang="en-US" dirty="0"/>
-              <a:t>Aperçu de la séance. Prévoir une pause entre le bestiaire et les ateliers d'écriture.</a:t>
+              <a:t>Aperçu de la séance. Prévoir une pause entre le bestiaire et les ateliers d'écriture. Public : adultes volontaires de tout acabit, sans prérequis. Annoncer la règle du joker dès le départ, et choisir des sujets qui font réfléchir sans viser l'identité ou le vécu intime des personnes présentes.</a:t>
             </a:r>
             <a:endParaRPr lang="en-US" dirty="0"/>
           </a:p>
@@ -2626,7 +2626,7 @@
           <a:p>
             <a:r>
               <a:rPr lang="en-US" dirty="0"/>
-              <a:t>Afficher en permanence dans la classe. La dernière phrase (Céder) est la plus difficile et la plus puissante. Défi de la semaine : l'utiliser une fois.</a:t>
+              <a:t>À afficher au travail, sur le frigo, ou à garder dans son portefeuille. La dernière phrase (Céder) est la plus difficile et la plus puissante. Défi de la semaine : l'utiliser une fois.</a:t>
             </a:r>
             <a:endParaRPr lang="en-US" dirty="0"/>
           </a:p>
@@ -3154,7 +3154,7 @@
           <a:p>
             <a:r>
               <a:rPr lang="en-US" dirty="0"/>
-              <a:t>Sujet : reprendre un énoncé de la ligne qui bouge. Les accords doivent porter sur le sujet, pas sur la météo. Le « Trop facile! » rend le jeu exigeant et drôle. Inclusion : pour un élève à mobilité réduite, le duo avance un jeton sur une piste dessinée au tableau. Retour : quel accord vous a le plus surpris? Lequel a été le plus difficile à dire?</a:t>
+              <a:t>Sujet : reprendre un énoncé de la ligne qui bouge. Les accords doivent porter sur le sujet, pas sur la météo. Le « Trop facile! » rend le jeu exigeant et drôle. Inclusion : pour une personne à mobilité réduite, le duo avance un jeton sur une piste dessinée au tableau. Retour : quel accord vous a le plus surpris? Lequel a été le plus difficile à dire?</a:t>
             </a:r>
             <a:endParaRPr lang="en-US" dirty="0"/>
           </a:p>
@@ -7121,7 +7121,7 @@
                   <a:schemeClr val="accent1"/>
                 </a:solidFill>
               </a:rPr>
-              <a:t>Ce que dit le programme</a:t>
+              <a:t>Les coups bas dans la vraie vie</a:t>
             </a:r>
             <a:endParaRPr lang="en-US" sz="3600" dirty="0"/>
           </a:p>
@@ -7136,7 +7136,7 @@
         <p:spPr>
           <a:xfrm>
             <a:off x="548640" y="1325880"/>
-            <a:ext cx="11064240" cy="731520"/>
+            <a:ext cx="11064240" cy="548640"/>
           </a:xfrm>
           <a:prstGeom prst="rect">
             <a:avLst/>
@@ -7160,7 +7160,7 @@
                 <a:ea typeface="Arial" pitchFamily="34" charset="-122"/>
                 <a:cs typeface="Arial" pitchFamily="34" charset="-120"/>
               </a:rPr>
-              <a:t>Culture et citoyenneté québécoise : la pratique du dialogue nomme des procédés qui entravent le dialogue. Schopenhauer en avait déjà décrit plusieurs.</a:t>
+              <a:t>Ils ne restent pas dans les livres de philosophie. On les croise chaque semaine.</a:t>
             </a:r>
             <a:endParaRPr lang="en-US" sz="1600" dirty="0"/>
           </a:p>
@@ -7174,8 +7174,8 @@
         </p:nvSpPr>
         <p:spPr>
           <a:xfrm>
-            <a:off x="822960" y="2240280"/>
-            <a:ext cx="4572000" cy="365760"/>
+            <a:off x="731520" y="2011680"/>
+            <a:ext cx="2286000" cy="365760"/>
           </a:xfrm>
           <a:prstGeom prst="rect">
             <a:avLst/>
@@ -7199,7 +7199,7 @@
                 <a:ea typeface="Arial" pitchFamily="34" charset="-122"/>
                 <a:cs typeface="Arial" pitchFamily="34" charset="-120"/>
               </a:rPr>
-              <a:t>Entrave au dialogue (CCQ)</a:t>
+              <a:t>Où</a:t>
             </a:r>
             <a:endParaRPr lang="en-US" sz="1400" dirty="0"/>
           </a:p>
@@ -7213,7 +7213,7 @@
         </p:nvSpPr>
         <p:spPr>
           <a:xfrm>
-            <a:off x="6766560" y="2240280"/>
+            <a:off x="3291840" y="2011680"/>
             <a:ext cx="4572000" cy="365760"/>
           </a:xfrm>
           <a:prstGeom prst="rect">
@@ -7238,7 +7238,7 @@
                 <a:ea typeface="Arial" pitchFamily="34" charset="-122"/>
                 <a:cs typeface="Arial" pitchFamily="34" charset="-120"/>
               </a:rPr>
-              <a:t>Stratagème de Schopenhauer</a:t>
+              <a:t>Ce qu'on entend</a:t>
             </a:r>
             <a:endParaRPr lang="en-US" sz="1400" dirty="0"/>
           </a:p>
@@ -7246,14 +7246,117 @@
       </p:sp>
       <p:sp>
         <p:nvSpPr>
-          <p:cNvPr id="6" name="Shape 4"/>
+          <p:cNvPr id="6" name="Text 4"/>
+          <p:cNvSpPr txBox="1"/>
+          <p:nvPr/>
+        </p:nvSpPr>
+        <p:spPr>
+          <a:xfrm>
+            <a:off x="8778240" y="2011680"/>
+            <a:ext cx="2743200" cy="365760"/>
+          </a:xfrm>
+          <a:prstGeom prst="rect">
+            <a:avLst/>
+          </a:prstGeom>
+          <a:noFill/>
+          <a:ln/>
+        </p:spPr>
+        <p:txBody>
+          <a:bodyPr wrap="square" lIns="0" tIns="0" rIns="0" bIns="0" rtlCol="0" anchor="t"/>
+          <a:lstStyle/>
+          <a:p>
+            <a:pPr indent="0" marL="0">
+              <a:buNone/>
+            </a:pPr>
+            <a:r>
+              <a:rPr lang="en-US" sz="1400" b="1" dirty="0">
+                <a:solidFill>
+                  <a:schemeClr val="tx2"/>
+                </a:solidFill>
+                <a:latin typeface="Arial" pitchFamily="34" charset="0"/>
+                <a:ea typeface="Arial" pitchFamily="34" charset="-122"/>
+                <a:cs typeface="Arial" pitchFamily="34" charset="-120"/>
+              </a:rPr>
+              <a:t>Le coup bas</a:t>
+            </a:r>
+            <a:endParaRPr lang="en-US" sz="1400" dirty="0"/>
+          </a:p>
+        </p:txBody>
+      </p:sp>
+      <p:sp>
+        <p:nvSpPr>
+          <p:cNvPr id="7" name="Shape 5"/>
           <p:cNvSpPr/>
           <p:nvPr/>
         </p:nvSpPr>
         <p:spPr>
           <a:xfrm>
-            <a:off x="548640" y="2697480"/>
-            <a:ext cx="4937760" cy="457200"/>
+            <a:off x="548640" y="2423160"/>
+            <a:ext cx="2560320" cy="512064"/>
+          </a:xfrm>
+          <a:prstGeom prst="rect">
+            <a:avLst/>
+          </a:prstGeom>
+          <a:solidFill>
+            <a:schemeClr val="tx1"/>
+          </a:solidFill>
+          <a:ln w="19050">
+            <a:solidFill>
+              <a:schemeClr val="tx1"/>
+            </a:solidFill>
+            <a:prstDash val="solid"/>
+          </a:ln>
+        </p:spPr>
+      </p:sp>
+      <p:sp>
+        <p:nvSpPr>
+          <p:cNvPr id="8" name="Text 6"/>
+          <p:cNvSpPr txBox="1"/>
+          <p:nvPr/>
+        </p:nvSpPr>
+        <p:spPr>
+          <a:xfrm>
+            <a:off x="685800" y="2423160"/>
+            <a:ext cx="2377440" cy="512064"/>
+          </a:xfrm>
+          <a:prstGeom prst="rect">
+            <a:avLst/>
+          </a:prstGeom>
+          <a:noFill/>
+          <a:ln/>
+        </p:spPr>
+        <p:txBody>
+          <a:bodyPr wrap="square" lIns="0" tIns="0" rIns="0" bIns="0" rtlCol="0" anchor="ctr"/>
+          <a:lstStyle/>
+          <a:p>
+            <a:pPr indent="0" marL="0">
+              <a:buNone/>
+            </a:pPr>
+            <a:r>
+              <a:rPr lang="en-US" sz="1500" b="1" dirty="0">
+                <a:solidFill>
+                  <a:schemeClr val="bg2"/>
+                </a:solidFill>
+                <a:latin typeface="Arial" pitchFamily="34" charset="0"/>
+                <a:ea typeface="Arial" pitchFamily="34" charset="-122"/>
+                <a:cs typeface="Arial" pitchFamily="34" charset="-120"/>
+              </a:rPr>
+              <a:t>Souper de famille</a:t>
+            </a:r>
+            <a:endParaRPr lang="en-US" sz="1500" dirty="0"/>
+          </a:p>
+        </p:txBody>
+      </p:sp>
+      <p:sp>
+        <p:nvSpPr>
+          <p:cNvPr id="9" name="Shape 7"/>
+          <p:cNvSpPr/>
+          <p:nvPr/>
+        </p:nvSpPr>
+        <p:spPr>
+          <a:xfrm>
+            <a:off x="3108960" y="2423160"/>
+            <a:ext cx="5486400" cy="512064"/>
           </a:xfrm>
           <a:prstGeom prst="rect">
             <a:avLst/>
@@ -7271,14 +7374,14 @@
       </p:sp>
       <p:sp>
         <p:nvSpPr>
-          <p:cNvPr id="7" name="Text 5"/>
-          <p:cNvSpPr txBox="1"/>
-          <p:nvPr/>
-        </p:nvSpPr>
-        <p:spPr>
-          <a:xfrm>
-            <a:off x="731520" y="2697480"/>
-            <a:ext cx="4663440" cy="457200"/>
+          <p:cNvPr id="10" name="Text 8"/>
+          <p:cNvSpPr txBox="1"/>
+          <p:nvPr/>
+        </p:nvSpPr>
+        <p:spPr>
+          <a:xfrm>
+            <a:off x="3291840" y="2423160"/>
+            <a:ext cx="5212080" cy="512064"/>
           </a:xfrm>
           <a:prstGeom prst="rect">
             <a:avLst/>
@@ -7294,7 +7397,7 @@
               <a:buNone/>
             </a:pPr>
             <a:r>
-              <a:rPr lang="en-US" sz="1500" b="1" dirty="0">
+              <a:rPr lang="en-US" sz="1500" i="1" dirty="0">
                 <a:solidFill>
                   <a:schemeClr val="tx1"/>
                 </a:solidFill>
@@ -7302,7 +7405,7 @@
                 <a:ea typeface="Arial" pitchFamily="34" charset="-122"/>
                 <a:cs typeface="Arial" pitchFamily="34" charset="-120"/>
               </a:rPr>
-              <a:t>Attaque personnelle</a:t>
+              <a:t>« Toi, de toute façon, t'as toujours été comme ça. »</a:t>
             </a:r>
             <a:endParaRPr lang="en-US" sz="1500" dirty="0"/>
           </a:p>
@@ -7310,38 +7413,14 @@
       </p:sp>
       <p:sp>
         <p:nvSpPr>
-          <p:cNvPr id="8" name="Shape 6"/>
+          <p:cNvPr id="11" name="Shape 9"/>
           <p:cNvSpPr/>
           <p:nvPr/>
         </p:nvSpPr>
         <p:spPr>
           <a:xfrm>
-            <a:off x="5577840" y="2926080"/>
-            <a:ext cx="914400" cy="0"/>
-          </a:xfrm>
-          <a:prstGeom prst="line">
-            <a:avLst/>
-          </a:prstGeom>
-          <a:noFill/>
-          <a:ln w="31750">
-            <a:solidFill>
-              <a:schemeClr val="accent1"/>
-            </a:solidFill>
-            <a:prstDash val="solid"/>
-            <a:tailEnd type="triangle"/>
-          </a:ln>
-        </p:spPr>
-      </p:sp>
-      <p:sp>
-        <p:nvSpPr>
-          <p:cNvPr id="9" name="Shape 7"/>
-          <p:cNvSpPr/>
-          <p:nvPr/>
-        </p:nvSpPr>
-        <p:spPr>
-          <a:xfrm>
-            <a:off x="6583680" y="2697480"/>
-            <a:ext cx="5029200" cy="457200"/>
+            <a:off x="8595360" y="2423160"/>
+            <a:ext cx="3017520" cy="512064"/>
           </a:xfrm>
           <a:prstGeom prst="rect">
             <a:avLst/>
@@ -7359,14 +7438,14 @@
       </p:sp>
       <p:sp>
         <p:nvSpPr>
-          <p:cNvPr id="10" name="Text 8"/>
-          <p:cNvSpPr txBox="1"/>
-          <p:nvPr/>
-        </p:nvSpPr>
-        <p:spPr>
-          <a:xfrm>
-            <a:off x="6766560" y="2697480"/>
-            <a:ext cx="4754880" cy="457200"/>
+          <p:cNvPr id="12" name="Text 10"/>
+          <p:cNvSpPr txBox="1"/>
+          <p:nvPr/>
+        </p:nvSpPr>
+        <p:spPr>
+          <a:xfrm>
+            <a:off x="8778240" y="2423160"/>
+            <a:ext cx="2743200" cy="512064"/>
           </a:xfrm>
           <a:prstGeom prst="rect">
             <a:avLst/>
@@ -7398,14 +7477,78 @@
       </p:sp>
       <p:sp>
         <p:nvSpPr>
-          <p:cNvPr id="11" name="Shape 9"/>
+          <p:cNvPr id="13" name="Shape 11"/>
           <p:cNvSpPr/>
           <p:nvPr/>
         </p:nvSpPr>
         <p:spPr>
           <a:xfrm>
-            <a:off x="548640" y="3264408"/>
-            <a:ext cx="4937760" cy="457200"/>
+            <a:off x="548640" y="3044952"/>
+            <a:ext cx="2560320" cy="512064"/>
+          </a:xfrm>
+          <a:prstGeom prst="rect">
+            <a:avLst/>
+          </a:prstGeom>
+          <a:solidFill>
+            <a:schemeClr val="tx1"/>
+          </a:solidFill>
+          <a:ln w="19050">
+            <a:solidFill>
+              <a:schemeClr val="tx1"/>
+            </a:solidFill>
+            <a:prstDash val="solid"/>
+          </a:ln>
+        </p:spPr>
+      </p:sp>
+      <p:sp>
+        <p:nvSpPr>
+          <p:cNvPr id="14" name="Text 12"/>
+          <p:cNvSpPr txBox="1"/>
+          <p:nvPr/>
+        </p:nvSpPr>
+        <p:spPr>
+          <a:xfrm>
+            <a:off x="685800" y="3044952"/>
+            <a:ext cx="2377440" cy="512064"/>
+          </a:xfrm>
+          <a:prstGeom prst="rect">
+            <a:avLst/>
+          </a:prstGeom>
+          <a:noFill/>
+          <a:ln/>
+        </p:spPr>
+        <p:txBody>
+          <a:bodyPr wrap="square" lIns="0" tIns="0" rIns="0" bIns="0" rtlCol="0" anchor="ctr"/>
+          <a:lstStyle/>
+          <a:p>
+            <a:pPr indent="0" marL="0">
+              <a:buNone/>
+            </a:pPr>
+            <a:r>
+              <a:rPr lang="en-US" sz="1500" b="1" dirty="0">
+                <a:solidFill>
+                  <a:schemeClr val="bg2"/>
+                </a:solidFill>
+                <a:latin typeface="Arial" pitchFamily="34" charset="0"/>
+                <a:ea typeface="Arial" pitchFamily="34" charset="-122"/>
+                <a:cs typeface="Arial" pitchFamily="34" charset="-120"/>
+              </a:rPr>
+              <a:t>Réunion d'équipe</a:t>
+            </a:r>
+            <a:endParaRPr lang="en-US" sz="1500" dirty="0"/>
+          </a:p>
+        </p:txBody>
+      </p:sp>
+      <p:sp>
+        <p:nvSpPr>
+          <p:cNvPr id="15" name="Shape 13"/>
+          <p:cNvSpPr/>
+          <p:nvPr/>
+        </p:nvSpPr>
+        <p:spPr>
+          <a:xfrm>
+            <a:off x="3108960" y="3044952"/>
+            <a:ext cx="5486400" cy="512064"/>
           </a:xfrm>
           <a:prstGeom prst="rect">
             <a:avLst/>
@@ -7423,14 +7566,14 @@
       </p:sp>
       <p:sp>
         <p:nvSpPr>
-          <p:cNvPr id="12" name="Text 10"/>
-          <p:cNvSpPr txBox="1"/>
-          <p:nvPr/>
-        </p:nvSpPr>
-        <p:spPr>
-          <a:xfrm>
-            <a:off x="731520" y="3264408"/>
-            <a:ext cx="4663440" cy="457200"/>
+          <p:cNvPr id="16" name="Text 14"/>
+          <p:cNvSpPr txBox="1"/>
+          <p:nvPr/>
+        </p:nvSpPr>
+        <p:spPr>
+          <a:xfrm>
+            <a:off x="3291840" y="3044952"/>
+            <a:ext cx="5212080" cy="512064"/>
           </a:xfrm>
           <a:prstGeom prst="rect">
             <a:avLst/>
@@ -7446,7 +7589,7 @@
               <a:buNone/>
             </a:pPr>
             <a:r>
-              <a:rPr lang="en-US" sz="1500" b="1" dirty="0">
+              <a:rPr lang="en-US" sz="1500" i="1" dirty="0">
                 <a:solidFill>
                   <a:schemeClr val="tx1"/>
                 </a:solidFill>
@@ -7454,7 +7597,7 @@
                 <a:ea typeface="Arial" pitchFamily="34" charset="-122"/>
                 <a:cs typeface="Arial" pitchFamily="34" charset="-120"/>
               </a:rPr>
-              <a:t>Caricature</a:t>
+              <a:t>« C'est ça ou on ferme le projet. »</a:t>
             </a:r>
             <a:endParaRPr lang="en-US" sz="1500" dirty="0"/>
           </a:p>
@@ -7462,38 +7605,14 @@
       </p:sp>
       <p:sp>
         <p:nvSpPr>
-          <p:cNvPr id="13" name="Shape 11"/>
+          <p:cNvPr id="17" name="Shape 15"/>
           <p:cNvSpPr/>
           <p:nvPr/>
         </p:nvSpPr>
         <p:spPr>
           <a:xfrm>
-            <a:off x="5577840" y="3493008"/>
-            <a:ext cx="914400" cy="0"/>
-          </a:xfrm>
-          <a:prstGeom prst="line">
-            <a:avLst/>
-          </a:prstGeom>
-          <a:noFill/>
-          <a:ln w="31750">
-            <a:solidFill>
-              <a:schemeClr val="accent1"/>
-            </a:solidFill>
-            <a:prstDash val="solid"/>
-            <a:tailEnd type="triangle"/>
-          </a:ln>
-        </p:spPr>
-      </p:sp>
-      <p:sp>
-        <p:nvSpPr>
-          <p:cNvPr id="14" name="Shape 12"/>
-          <p:cNvSpPr/>
-          <p:nvPr/>
-        </p:nvSpPr>
-        <p:spPr>
-          <a:xfrm>
-            <a:off x="6583680" y="3264408"/>
-            <a:ext cx="5029200" cy="457200"/>
+            <a:off x="8595360" y="3044952"/>
+            <a:ext cx="3017520" cy="512064"/>
           </a:xfrm>
           <a:prstGeom prst="rect">
             <a:avLst/>
@@ -7511,14 +7630,14 @@
       </p:sp>
       <p:sp>
         <p:nvSpPr>
-          <p:cNvPr id="15" name="Text 13"/>
-          <p:cNvSpPr txBox="1"/>
-          <p:nvPr/>
-        </p:nvSpPr>
-        <p:spPr>
-          <a:xfrm>
-            <a:off x="6766560" y="3264408"/>
-            <a:ext cx="4754880" cy="457200"/>
+          <p:cNvPr id="18" name="Text 16"/>
+          <p:cNvSpPr txBox="1"/>
+          <p:nvPr/>
+        </p:nvSpPr>
+        <p:spPr>
+          <a:xfrm>
+            <a:off x="8778240" y="3044952"/>
+            <a:ext cx="2743200" cy="512064"/>
           </a:xfrm>
           <a:prstGeom prst="rect">
             <a:avLst/>
@@ -7542,7 +7661,7 @@
                 <a:ea typeface="Arial" pitchFamily="34" charset="-122"/>
                 <a:cs typeface="Arial" pitchFamily="34" charset="-120"/>
               </a:rPr>
-              <a:t>1 · L'élastique</a:t>
+              <a:t>13 · Le faux choix</a:t>
             </a:r>
             <a:endParaRPr lang="en-US" sz="1500" dirty="0"/>
           </a:p>
@@ -7550,14 +7669,78 @@
       </p:sp>
       <p:sp>
         <p:nvSpPr>
-          <p:cNvPr id="16" name="Shape 14"/>
+          <p:cNvPr id="19" name="Shape 17"/>
           <p:cNvSpPr/>
           <p:nvPr/>
         </p:nvSpPr>
         <p:spPr>
           <a:xfrm>
-            <a:off x="548640" y="3831336"/>
-            <a:ext cx="4937760" cy="457200"/>
+            <a:off x="548640" y="3666744"/>
+            <a:ext cx="2560320" cy="512064"/>
+          </a:xfrm>
+          <a:prstGeom prst="rect">
+            <a:avLst/>
+          </a:prstGeom>
+          <a:solidFill>
+            <a:schemeClr val="tx1"/>
+          </a:solidFill>
+          <a:ln w="19050">
+            <a:solidFill>
+              <a:schemeClr val="tx1"/>
+            </a:solidFill>
+            <a:prstDash val="solid"/>
+          </a:ln>
+        </p:spPr>
+      </p:sp>
+      <p:sp>
+        <p:nvSpPr>
+          <p:cNvPr id="20" name="Text 18"/>
+          <p:cNvSpPr txBox="1"/>
+          <p:nvPr/>
+        </p:nvSpPr>
+        <p:spPr>
+          <a:xfrm>
+            <a:off x="685800" y="3666744"/>
+            <a:ext cx="2377440" cy="512064"/>
+          </a:xfrm>
+          <a:prstGeom prst="rect">
+            <a:avLst/>
+          </a:prstGeom>
+          <a:noFill/>
+          <a:ln/>
+        </p:spPr>
+        <p:txBody>
+          <a:bodyPr wrap="square" lIns="0" tIns="0" rIns="0" bIns="0" rtlCol="0" anchor="ctr"/>
+          <a:lstStyle/>
+          <a:p>
+            <a:pPr indent="0" marL="0">
+              <a:buNone/>
+            </a:pPr>
+            <a:r>
+              <a:rPr lang="en-US" sz="1500" b="1" dirty="0">
+                <a:solidFill>
+                  <a:schemeClr val="bg2"/>
+                </a:solidFill>
+                <a:latin typeface="Arial" pitchFamily="34" charset="0"/>
+                <a:ea typeface="Arial" pitchFamily="34" charset="-122"/>
+                <a:cs typeface="Arial" pitchFamily="34" charset="-120"/>
+              </a:rPr>
+              <a:t>Réseaux sociaux</a:t>
+            </a:r>
+            <a:endParaRPr lang="en-US" sz="1500" dirty="0"/>
+          </a:p>
+        </p:txBody>
+      </p:sp>
+      <p:sp>
+        <p:nvSpPr>
+          <p:cNvPr id="21" name="Shape 19"/>
+          <p:cNvSpPr/>
+          <p:nvPr/>
+        </p:nvSpPr>
+        <p:spPr>
+          <a:xfrm>
+            <a:off x="3108960" y="3666744"/>
+            <a:ext cx="5486400" cy="512064"/>
           </a:xfrm>
           <a:prstGeom prst="rect">
             <a:avLst/>
@@ -7575,14 +7758,14 @@
       </p:sp>
       <p:sp>
         <p:nvSpPr>
-          <p:cNvPr id="17" name="Text 15"/>
-          <p:cNvSpPr txBox="1"/>
-          <p:nvPr/>
-        </p:nvSpPr>
-        <p:spPr>
-          <a:xfrm>
-            <a:off x="731520" y="3831336"/>
-            <a:ext cx="4663440" cy="457200"/>
+          <p:cNvPr id="22" name="Text 20"/>
+          <p:cNvSpPr txBox="1"/>
+          <p:nvPr/>
+        </p:nvSpPr>
+        <p:spPr>
+          <a:xfrm>
+            <a:off x="3291840" y="3666744"/>
+            <a:ext cx="5212080" cy="512064"/>
           </a:xfrm>
           <a:prstGeom prst="rect">
             <a:avLst/>
@@ -7598,7 +7781,7 @@
               <a:buNone/>
             </a:pPr>
             <a:r>
-              <a:rPr lang="en-US" sz="1500" b="1" dirty="0">
+              <a:rPr lang="en-US" sz="1500" i="1" dirty="0">
                 <a:solidFill>
                   <a:schemeClr val="tx1"/>
                 </a:solidFill>
@@ -7606,7 +7789,7 @@
                 <a:ea typeface="Arial" pitchFamily="34" charset="-122"/>
                 <a:cs typeface="Arial" pitchFamily="34" charset="-120"/>
               </a:rPr>
-              <a:t>Faux dilemme</a:t>
+              <a:t>« Donc tu veux qu'on abolisse la police? »</a:t>
             </a:r>
             <a:endParaRPr lang="en-US" sz="1500" dirty="0"/>
           </a:p>
@@ -7614,38 +7797,14 @@
       </p:sp>
       <p:sp>
         <p:nvSpPr>
-          <p:cNvPr id="18" name="Shape 16"/>
+          <p:cNvPr id="23" name="Shape 21"/>
           <p:cNvSpPr/>
           <p:nvPr/>
         </p:nvSpPr>
         <p:spPr>
           <a:xfrm>
-            <a:off x="5577840" y="4059936"/>
-            <a:ext cx="914400" cy="0"/>
-          </a:xfrm>
-          <a:prstGeom prst="line">
-            <a:avLst/>
-          </a:prstGeom>
-          <a:noFill/>
-          <a:ln w="31750">
-            <a:solidFill>
-              <a:schemeClr val="accent1"/>
-            </a:solidFill>
-            <a:prstDash val="solid"/>
-            <a:tailEnd type="triangle"/>
-          </a:ln>
-        </p:spPr>
-      </p:sp>
-      <p:sp>
-        <p:nvSpPr>
-          <p:cNvPr id="19" name="Shape 17"/>
-          <p:cNvSpPr/>
-          <p:nvPr/>
-        </p:nvSpPr>
-        <p:spPr>
-          <a:xfrm>
-            <a:off x="6583680" y="3831336"/>
-            <a:ext cx="5029200" cy="457200"/>
+            <a:off x="8595360" y="3666744"/>
+            <a:ext cx="3017520" cy="512064"/>
           </a:xfrm>
           <a:prstGeom prst="rect">
             <a:avLst/>
@@ -7663,14 +7822,14 @@
       </p:sp>
       <p:sp>
         <p:nvSpPr>
-          <p:cNvPr id="20" name="Text 18"/>
-          <p:cNvSpPr txBox="1"/>
-          <p:nvPr/>
-        </p:nvSpPr>
-        <p:spPr>
-          <a:xfrm>
-            <a:off x="6766560" y="3831336"/>
-            <a:ext cx="4754880" cy="457200"/>
+          <p:cNvPr id="24" name="Text 22"/>
+          <p:cNvSpPr txBox="1"/>
+          <p:nvPr/>
+        </p:nvSpPr>
+        <p:spPr>
+          <a:xfrm>
+            <a:off x="8778240" y="3666744"/>
+            <a:ext cx="2743200" cy="512064"/>
           </a:xfrm>
           <a:prstGeom prst="rect">
             <a:avLst/>
@@ -7694,7 +7853,7 @@
                 <a:ea typeface="Arial" pitchFamily="34" charset="-122"/>
                 <a:cs typeface="Arial" pitchFamily="34" charset="-120"/>
               </a:rPr>
-              <a:t>13 · Le faux choix</a:t>
+              <a:t>1 · L'élastique</a:t>
             </a:r>
             <a:endParaRPr lang="en-US" sz="1500" dirty="0"/>
           </a:p>
@@ -7702,14 +7861,78 @@
       </p:sp>
       <p:sp>
         <p:nvSpPr>
-          <p:cNvPr id="21" name="Shape 19"/>
+          <p:cNvPr id="25" name="Shape 23"/>
           <p:cNvSpPr/>
           <p:nvPr/>
         </p:nvSpPr>
         <p:spPr>
           <a:xfrm>
-            <a:off x="548640" y="4398264"/>
-            <a:ext cx="4937760" cy="457200"/>
+            <a:off x="548640" y="4288536"/>
+            <a:ext cx="2560320" cy="512064"/>
+          </a:xfrm>
+          <a:prstGeom prst="rect">
+            <a:avLst/>
+          </a:prstGeom>
+          <a:solidFill>
+            <a:schemeClr val="tx1"/>
+          </a:solidFill>
+          <a:ln w="19050">
+            <a:solidFill>
+              <a:schemeClr val="tx1"/>
+            </a:solidFill>
+            <a:prstDash val="solid"/>
+          </a:ln>
+        </p:spPr>
+      </p:sp>
+      <p:sp>
+        <p:nvSpPr>
+          <p:cNvPr id="26" name="Text 24"/>
+          <p:cNvSpPr txBox="1"/>
+          <p:nvPr/>
+        </p:nvSpPr>
+        <p:spPr>
+          <a:xfrm>
+            <a:off x="685800" y="4288536"/>
+            <a:ext cx="2377440" cy="512064"/>
+          </a:xfrm>
+          <a:prstGeom prst="rect">
+            <a:avLst/>
+          </a:prstGeom>
+          <a:noFill/>
+          <a:ln/>
+        </p:spPr>
+        <p:txBody>
+          <a:bodyPr wrap="square" lIns="0" tIns="0" rIns="0" bIns="0" rtlCol="0" anchor="ctr"/>
+          <a:lstStyle/>
+          <a:p>
+            <a:pPr indent="0" marL="0">
+              <a:buNone/>
+            </a:pPr>
+            <a:r>
+              <a:rPr lang="en-US" sz="1500" b="1" dirty="0">
+                <a:solidFill>
+                  <a:schemeClr val="bg2"/>
+                </a:solidFill>
+                <a:latin typeface="Arial" pitchFamily="34" charset="0"/>
+                <a:ea typeface="Arial" pitchFamily="34" charset="-122"/>
+                <a:cs typeface="Arial" pitchFamily="34" charset="-120"/>
+              </a:rPr>
+              <a:t>Conseil municipal</a:t>
+            </a:r>
+            <a:endParaRPr lang="en-US" sz="1500" dirty="0"/>
+          </a:p>
+        </p:txBody>
+      </p:sp>
+      <p:sp>
+        <p:nvSpPr>
+          <p:cNvPr id="27" name="Shape 25"/>
+          <p:cNvSpPr/>
+          <p:nvPr/>
+        </p:nvSpPr>
+        <p:spPr>
+          <a:xfrm>
+            <a:off x="3108960" y="4288536"/>
+            <a:ext cx="5486400" cy="512064"/>
           </a:xfrm>
           <a:prstGeom prst="rect">
             <a:avLst/>
@@ -7727,14 +7950,14 @@
       </p:sp>
       <p:sp>
         <p:nvSpPr>
-          <p:cNvPr id="22" name="Text 20"/>
-          <p:cNvSpPr txBox="1"/>
-          <p:nvPr/>
-        </p:nvSpPr>
-        <p:spPr>
-          <a:xfrm>
-            <a:off x="731520" y="4398264"/>
-            <a:ext cx="4663440" cy="457200"/>
+          <p:cNvPr id="28" name="Text 26"/>
+          <p:cNvSpPr txBox="1"/>
+          <p:nvPr/>
+        </p:nvSpPr>
+        <p:spPr>
+          <a:xfrm>
+            <a:off x="3291840" y="4288536"/>
+            <a:ext cx="5212080" cy="512064"/>
           </a:xfrm>
           <a:prstGeom prst="rect">
             <a:avLst/>
@@ -7750,7 +7973,7 @@
               <a:buNone/>
             </a:pPr>
             <a:r>
-              <a:rPr lang="en-US" sz="1500" b="1" dirty="0">
+              <a:rPr lang="en-US" sz="1500" i="1" dirty="0">
                 <a:solidFill>
                   <a:schemeClr val="tx1"/>
                 </a:solidFill>
@@ -7758,7 +7981,7 @@
                 <a:ea typeface="Arial" pitchFamily="34" charset="-122"/>
                 <a:cs typeface="Arial" pitchFamily="34" charset="-120"/>
               </a:rPr>
-              <a:t>Argument d'autorité</a:t>
+              <a:t>« Ça, c'est une idée de radicaux. »</a:t>
             </a:r>
             <a:endParaRPr lang="en-US" sz="1500" dirty="0"/>
           </a:p>
@@ -7766,38 +7989,14 @@
       </p:sp>
       <p:sp>
         <p:nvSpPr>
-          <p:cNvPr id="23" name="Shape 21"/>
+          <p:cNvPr id="29" name="Shape 27"/>
           <p:cNvSpPr/>
           <p:nvPr/>
         </p:nvSpPr>
         <p:spPr>
           <a:xfrm>
-            <a:off x="5577840" y="4626864"/>
-            <a:ext cx="914400" cy="0"/>
-          </a:xfrm>
-          <a:prstGeom prst="line">
-            <a:avLst/>
-          </a:prstGeom>
-          <a:noFill/>
-          <a:ln w="31750">
-            <a:solidFill>
-              <a:schemeClr val="accent1"/>
-            </a:solidFill>
-            <a:prstDash val="solid"/>
-            <a:tailEnd type="triangle"/>
-          </a:ln>
-        </p:spPr>
-      </p:sp>
-      <p:sp>
-        <p:nvSpPr>
-          <p:cNvPr id="24" name="Shape 22"/>
-          <p:cNvSpPr/>
-          <p:nvPr/>
-        </p:nvSpPr>
-        <p:spPr>
-          <a:xfrm>
-            <a:off x="6583680" y="4398264"/>
-            <a:ext cx="5029200" cy="457200"/>
+            <a:off x="8595360" y="4288536"/>
+            <a:ext cx="3017520" cy="512064"/>
           </a:xfrm>
           <a:prstGeom prst="rect">
             <a:avLst/>
@@ -7815,14 +8014,14 @@
       </p:sp>
       <p:sp>
         <p:nvSpPr>
-          <p:cNvPr id="25" name="Text 23"/>
-          <p:cNvSpPr txBox="1"/>
-          <p:nvPr/>
-        </p:nvSpPr>
-        <p:spPr>
-          <a:xfrm>
-            <a:off x="6766560" y="4398264"/>
-            <a:ext cx="4754880" cy="457200"/>
+          <p:cNvPr id="30" name="Text 28"/>
+          <p:cNvSpPr txBox="1"/>
+          <p:nvPr/>
+        </p:nvSpPr>
+        <p:spPr>
+          <a:xfrm>
+            <a:off x="8778240" y="4288536"/>
+            <a:ext cx="2743200" cy="512064"/>
           </a:xfrm>
           <a:prstGeom prst="rect">
             <a:avLst/>
@@ -7846,7 +8045,7 @@
                 <a:ea typeface="Arial" pitchFamily="34" charset="-122"/>
                 <a:cs typeface="Arial" pitchFamily="34" charset="-120"/>
               </a:rPr>
-              <a:t>30 · Le galon</a:t>
+              <a:t>32 · L'étiquette</a:t>
             </a:r>
             <a:endParaRPr lang="en-US" sz="1500" dirty="0"/>
           </a:p>
@@ -7854,14 +8053,78 @@
       </p:sp>
       <p:sp>
         <p:nvSpPr>
-          <p:cNvPr id="26" name="Shape 24"/>
+          <p:cNvPr id="31" name="Shape 29"/>
           <p:cNvSpPr/>
           <p:nvPr/>
         </p:nvSpPr>
         <p:spPr>
           <a:xfrm>
-            <a:off x="548640" y="4965192"/>
-            <a:ext cx="4937760" cy="457200"/>
+            <a:off x="548640" y="4910328"/>
+            <a:ext cx="2560320" cy="512064"/>
+          </a:xfrm>
+          <a:prstGeom prst="rect">
+            <a:avLst/>
+          </a:prstGeom>
+          <a:solidFill>
+            <a:schemeClr val="tx1"/>
+          </a:solidFill>
+          <a:ln w="19050">
+            <a:solidFill>
+              <a:schemeClr val="tx1"/>
+            </a:solidFill>
+            <a:prstDash val="solid"/>
+          </a:ln>
+        </p:spPr>
+      </p:sp>
+      <p:sp>
+        <p:nvSpPr>
+          <p:cNvPr id="32" name="Text 30"/>
+          <p:cNvSpPr txBox="1"/>
+          <p:nvPr/>
+        </p:nvSpPr>
+        <p:spPr>
+          <a:xfrm>
+            <a:off x="685800" y="4910328"/>
+            <a:ext cx="2377440" cy="512064"/>
+          </a:xfrm>
+          <a:prstGeom prst="rect">
+            <a:avLst/>
+          </a:prstGeom>
+          <a:noFill/>
+          <a:ln/>
+        </p:spPr>
+        <p:txBody>
+          <a:bodyPr wrap="square" lIns="0" tIns="0" rIns="0" bIns="0" rtlCol="0" anchor="ctr"/>
+          <a:lstStyle/>
+          <a:p>
+            <a:pPr indent="0" marL="0">
+              <a:buNone/>
+            </a:pPr>
+            <a:r>
+              <a:rPr lang="en-US" sz="1500" b="1" dirty="0">
+                <a:solidFill>
+                  <a:schemeClr val="bg2"/>
+                </a:solidFill>
+                <a:latin typeface="Arial" pitchFamily="34" charset="0"/>
+                <a:ea typeface="Arial" pitchFamily="34" charset="-122"/>
+                <a:cs typeface="Arial" pitchFamily="34" charset="-120"/>
+              </a:rPr>
+              <a:t>Entre ami·es</a:t>
+            </a:r>
+            <a:endParaRPr lang="en-US" sz="1500" dirty="0"/>
+          </a:p>
+        </p:txBody>
+      </p:sp>
+      <p:sp>
+        <p:nvSpPr>
+          <p:cNvPr id="33" name="Shape 31"/>
+          <p:cNvSpPr/>
+          <p:nvPr/>
+        </p:nvSpPr>
+        <p:spPr>
+          <a:xfrm>
+            <a:off x="3108960" y="4910328"/>
+            <a:ext cx="5486400" cy="512064"/>
           </a:xfrm>
           <a:prstGeom prst="rect">
             <a:avLst/>
@@ -7879,14 +8142,14 @@
       </p:sp>
       <p:sp>
         <p:nvSpPr>
-          <p:cNvPr id="27" name="Text 25"/>
-          <p:cNvSpPr txBox="1"/>
-          <p:nvPr/>
-        </p:nvSpPr>
-        <p:spPr>
-          <a:xfrm>
-            <a:off x="731520" y="4965192"/>
-            <a:ext cx="4663440" cy="457200"/>
+          <p:cNvPr id="34" name="Text 32"/>
+          <p:cNvSpPr txBox="1"/>
+          <p:nvPr/>
+        </p:nvSpPr>
+        <p:spPr>
+          <a:xfrm>
+            <a:off x="3291840" y="4910328"/>
+            <a:ext cx="5212080" cy="512064"/>
           </a:xfrm>
           <a:prstGeom prst="rect">
             <a:avLst/>
@@ -7902,7 +8165,7 @@
               <a:buNone/>
             </a:pPr>
             <a:r>
-              <a:rPr lang="en-US" sz="1500" b="1" dirty="0">
+              <a:rPr lang="en-US" sz="1500" i="1" dirty="0">
                 <a:solidFill>
                   <a:schemeClr val="tx1"/>
                 </a:solidFill>
@@ -7910,7 +8173,7 @@
                 <a:ea typeface="Arial" pitchFamily="34" charset="-122"/>
                 <a:cs typeface="Arial" pitchFamily="34" charset="-120"/>
               </a:rPr>
-              <a:t>Appel au clan / au préjugé</a:t>
+              <a:t>« Un médecin l'a dit à la télé, c'est réglé. »</a:t>
             </a:r>
             <a:endParaRPr lang="en-US" sz="1500" dirty="0"/>
           </a:p>
@@ -7918,38 +8181,14 @@
       </p:sp>
       <p:sp>
         <p:nvSpPr>
-          <p:cNvPr id="28" name="Shape 26"/>
+          <p:cNvPr id="35" name="Shape 33"/>
           <p:cNvSpPr/>
           <p:nvPr/>
         </p:nvSpPr>
         <p:spPr>
           <a:xfrm>
-            <a:off x="5577840" y="5193792"/>
-            <a:ext cx="914400" cy="0"/>
-          </a:xfrm>
-          <a:prstGeom prst="line">
-            <a:avLst/>
-          </a:prstGeom>
-          <a:noFill/>
-          <a:ln w="31750">
-            <a:solidFill>
-              <a:schemeClr val="accent1"/>
-            </a:solidFill>
-            <a:prstDash val="solid"/>
-            <a:tailEnd type="triangle"/>
-          </a:ln>
-        </p:spPr>
-      </p:sp>
-      <p:sp>
-        <p:nvSpPr>
-          <p:cNvPr id="29" name="Shape 27"/>
-          <p:cNvSpPr/>
-          <p:nvPr/>
-        </p:nvSpPr>
-        <p:spPr>
-          <a:xfrm>
-            <a:off x="6583680" y="4965192"/>
-            <a:ext cx="5029200" cy="457200"/>
+            <a:off x="8595360" y="4910328"/>
+            <a:ext cx="3017520" cy="512064"/>
           </a:xfrm>
           <a:prstGeom prst="rect">
             <a:avLst/>
@@ -7967,14 +8206,14 @@
       </p:sp>
       <p:sp>
         <p:nvSpPr>
-          <p:cNvPr id="30" name="Text 28"/>
-          <p:cNvSpPr txBox="1"/>
-          <p:nvPr/>
-        </p:nvSpPr>
-        <p:spPr>
-          <a:xfrm>
-            <a:off x="6766560" y="4965192"/>
-            <a:ext cx="4754880" cy="457200"/>
+          <p:cNvPr id="36" name="Text 34"/>
+          <p:cNvSpPr txBox="1"/>
+          <p:nvPr/>
+        </p:nvSpPr>
+        <p:spPr>
+          <a:xfrm>
+            <a:off x="8778240" y="4910328"/>
+            <a:ext cx="2743200" cy="512064"/>
           </a:xfrm>
           <a:prstGeom prst="rect">
             <a:avLst/>
@@ -7998,7 +8237,7 @@
                 <a:ea typeface="Arial" pitchFamily="34" charset="-122"/>
                 <a:cs typeface="Arial" pitchFamily="34" charset="-120"/>
               </a:rPr>
-              <a:t>32 · L'étiquette</a:t>
+              <a:t>30 · Le galon</a:t>
             </a:r>
             <a:endParaRPr lang="en-US" sz="1500" dirty="0"/>
           </a:p>
@@ -8006,14 +8245,78 @@
       </p:sp>
       <p:sp>
         <p:nvSpPr>
-          <p:cNvPr id="31" name="Shape 29"/>
+          <p:cNvPr id="37" name="Shape 35"/>
           <p:cNvSpPr/>
           <p:nvPr/>
         </p:nvSpPr>
         <p:spPr>
           <a:xfrm>
             <a:off x="548640" y="5532120"/>
-            <a:ext cx="4937760" cy="457200"/>
+            <a:ext cx="2560320" cy="512064"/>
+          </a:xfrm>
+          <a:prstGeom prst="rect">
+            <a:avLst/>
+          </a:prstGeom>
+          <a:solidFill>
+            <a:schemeClr val="tx1"/>
+          </a:solidFill>
+          <a:ln w="19050">
+            <a:solidFill>
+              <a:schemeClr val="tx1"/>
+            </a:solidFill>
+            <a:prstDash val="solid"/>
+          </a:ln>
+        </p:spPr>
+      </p:sp>
+      <p:sp>
+        <p:nvSpPr>
+          <p:cNvPr id="38" name="Text 36"/>
+          <p:cNvSpPr txBox="1"/>
+          <p:nvPr/>
+        </p:nvSpPr>
+        <p:spPr>
+          <a:xfrm>
+            <a:off x="685800" y="5532120"/>
+            <a:ext cx="2377440" cy="512064"/>
+          </a:xfrm>
+          <a:prstGeom prst="rect">
+            <a:avLst/>
+          </a:prstGeom>
+          <a:noFill/>
+          <a:ln/>
+        </p:spPr>
+        <p:txBody>
+          <a:bodyPr wrap="square" lIns="0" tIns="0" rIns="0" bIns="0" rtlCol="0" anchor="ctr"/>
+          <a:lstStyle/>
+          <a:p>
+            <a:pPr indent="0" marL="0">
+              <a:buNone/>
+            </a:pPr>
+            <a:r>
+              <a:rPr lang="en-US" sz="1500" b="1" dirty="0">
+                <a:solidFill>
+                  <a:schemeClr val="bg2"/>
+                </a:solidFill>
+                <a:latin typeface="Arial" pitchFamily="34" charset="0"/>
+                <a:ea typeface="Arial" pitchFamily="34" charset="-122"/>
+                <a:cs typeface="Arial" pitchFamily="34" charset="-120"/>
+              </a:rPr>
+              <a:t>Couple</a:t>
+            </a:r>
+            <a:endParaRPr lang="en-US" sz="1500" dirty="0"/>
+          </a:p>
+        </p:txBody>
+      </p:sp>
+      <p:sp>
+        <p:nvSpPr>
+          <p:cNvPr id="39" name="Shape 37"/>
+          <p:cNvSpPr/>
+          <p:nvPr/>
+        </p:nvSpPr>
+        <p:spPr>
+          <a:xfrm>
+            <a:off x="3108960" y="5532120"/>
+            <a:ext cx="5486400" cy="512064"/>
           </a:xfrm>
           <a:prstGeom prst="rect">
             <a:avLst/>
@@ -8031,14 +8334,14 @@
       </p:sp>
       <p:sp>
         <p:nvSpPr>
-          <p:cNvPr id="32" name="Text 30"/>
-          <p:cNvSpPr txBox="1"/>
-          <p:nvPr/>
-        </p:nvSpPr>
-        <p:spPr>
-          <a:xfrm>
-            <a:off x="731520" y="5532120"/>
-            <a:ext cx="4663440" cy="457200"/>
+          <p:cNvPr id="40" name="Text 38"/>
+          <p:cNvSpPr txBox="1"/>
+          <p:nvPr/>
+        </p:nvSpPr>
+        <p:spPr>
+          <a:xfrm>
+            <a:off x="3291840" y="5532120"/>
+            <a:ext cx="5212080" cy="512064"/>
           </a:xfrm>
           <a:prstGeom prst="rect">
             <a:avLst/>
@@ -8054,7 +8357,7 @@
               <a:buNone/>
             </a:pPr>
             <a:r>
-              <a:rPr lang="en-US" sz="1500" b="1" dirty="0">
+              <a:rPr lang="en-US" sz="1500" i="1" dirty="0">
                 <a:solidFill>
                   <a:schemeClr val="tx1"/>
                 </a:solidFill>
@@ -8062,7 +8365,7 @@
                 <a:ea typeface="Arial" pitchFamily="34" charset="-122"/>
                 <a:cs typeface="Arial" pitchFamily="34" charset="-120"/>
               </a:rPr>
-              <a:t>Diversion (hors programme)</a:t>
+              <a:t>« Pis toi, la semaine passée, hein? »</a:t>
             </a:r>
             <a:endParaRPr lang="en-US" sz="1500" dirty="0"/>
           </a:p>
@@ -8070,38 +8373,14 @@
       </p:sp>
       <p:sp>
         <p:nvSpPr>
-          <p:cNvPr id="33" name="Shape 31"/>
+          <p:cNvPr id="41" name="Shape 39"/>
           <p:cNvSpPr/>
           <p:nvPr/>
         </p:nvSpPr>
         <p:spPr>
           <a:xfrm>
-            <a:off x="5577840" y="5760720"/>
-            <a:ext cx="914400" cy="0"/>
-          </a:xfrm>
-          <a:prstGeom prst="line">
-            <a:avLst/>
-          </a:prstGeom>
-          <a:noFill/>
-          <a:ln w="31750">
-            <a:solidFill>
-              <a:schemeClr val="accent1"/>
-            </a:solidFill>
-            <a:prstDash val="solid"/>
-            <a:tailEnd type="triangle"/>
-          </a:ln>
-        </p:spPr>
-      </p:sp>
-      <p:sp>
-        <p:nvSpPr>
-          <p:cNvPr id="34" name="Shape 32"/>
-          <p:cNvSpPr/>
-          <p:nvPr/>
-        </p:nvSpPr>
-        <p:spPr>
-          <a:xfrm>
-            <a:off x="6583680" y="5532120"/>
-            <a:ext cx="5029200" cy="457200"/>
+            <a:off x="8595360" y="5532120"/>
+            <a:ext cx="3017520" cy="512064"/>
           </a:xfrm>
           <a:prstGeom prst="rect">
             <a:avLst/>
@@ -8119,14 +8398,14 @@
       </p:sp>
       <p:sp>
         <p:nvSpPr>
-          <p:cNvPr id="35" name="Text 33"/>
-          <p:cNvSpPr txBox="1"/>
-          <p:nvPr/>
-        </p:nvSpPr>
-        <p:spPr>
-          <a:xfrm>
-            <a:off x="6766560" y="5532120"/>
-            <a:ext cx="4754880" cy="457200"/>
+          <p:cNvPr id="42" name="Text 40"/>
+          <p:cNvSpPr txBox="1"/>
+          <p:nvPr/>
+        </p:nvSpPr>
+        <p:spPr>
+          <a:xfrm>
+            <a:off x="8778240" y="5532120"/>
+            <a:ext cx="2743200" cy="512064"/>
           </a:xfrm>
           <a:prstGeom prst="rect">
             <a:avLst/>
@@ -8964,7 +9243,7 @@
                 <a:ea typeface="Arial" pitchFamily="34" charset="-122"/>
                 <a:cs typeface="Arial" pitchFamily="34" charset="-120"/>
               </a:rPr>
-              <a:t>« Tu dis ça parce que t'es jeune. »</a:t>
+              <a:t>« Tu dis ça parce que t'es de ta génération. »</a:t>
             </a:r>
             <a:endParaRPr lang="en-US" sz="1300" dirty="0"/>
           </a:p>
@@ -17602,7 +17881,7 @@
                 <a:ea typeface="Arial" pitchFamily="34" charset="-122"/>
                 <a:cs typeface="Arial" pitchFamily="34" charset="-120"/>
               </a:rPr>
-              <a:t>6 minutes sur un vrai sujet de classe. Chacun joue sa créature… sans la nommer.</a:t>
+              <a:t>6 minutes sur un vrai sujet de société. Chacun joue sa créature… sans la nommer.</a:t>
             </a:r>
             <a:endParaRPr lang="en-US" sz="1400" dirty="0"/>
           </a:p>
@@ -18135,7 +18414,7 @@
                 <a:ea typeface="Arial" pitchFamily="34" charset="-122"/>
                 <a:cs typeface="Arial" pitchFamily="34" charset="-120"/>
               </a:rPr>
-              <a:t>Uniforme obligatoire?</a:t>
+              <a:t>La semaine de 4 jours au travail?</a:t>
             </a:r>
             <a:endParaRPr lang="en-US" sz="1500" dirty="0"/>
           </a:p>
@@ -18156,7 +18435,7 @@
                 <a:ea typeface="Arial" pitchFamily="34" charset="-122"/>
                 <a:cs typeface="Arial" pitchFamily="34" charset="-120"/>
               </a:rPr>
-              <a:t>Une semaine de 4 jours à l'école?</a:t>
+              <a:t>Bannir les cellulaires au restaurant?</a:t>
             </a:r>
             <a:endParaRPr lang="en-US" sz="1500" dirty="0"/>
           </a:p>
@@ -18177,7 +18456,7 @@
                 <a:ea typeface="Arial" pitchFamily="34" charset="-122"/>
                 <a:cs typeface="Arial" pitchFamily="34" charset="-120"/>
               </a:rPr>
-              <a:t>Les notes devraient-elles disparaître?</a:t>
+              <a:t>Le pourboire devrait-il disparaître?</a:t>
             </a:r>
             <a:endParaRPr lang="en-US" sz="1500" dirty="0"/>
           </a:p>
@@ -18198,7 +18477,7 @@
                 <a:ea typeface="Arial" pitchFamily="34" charset="-122"/>
                 <a:cs typeface="Arial" pitchFamily="34" charset="-120"/>
               </a:rPr>
-              <a:t>L'IA pour faire ses devoirs : tricherie ou outil?</a:t>
+              <a:t>L'IA au travail : outil ou menace?</a:t>
             </a:r>
             <a:endParaRPr lang="en-US" sz="1500" dirty="0"/>
           </a:p>
@@ -18309,7 +18588,7 @@
                   <a:schemeClr val="accent1"/>
                 </a:solidFill>
               </a:rPr>
-              <a:t>Bingo des coups bas · grille de l'observateur</a:t>
+              <a:t>Bingo des coups bas</a:t>
             </a:r>
             <a:endParaRPr lang="en-US" sz="3600" dirty="0"/>
           </a:p>
@@ -20287,7 +20566,7 @@
                 <a:ea typeface="Arial" pitchFamily="34" charset="-122"/>
                 <a:cs typeface="Arial" pitchFamily="34" charset="-120"/>
               </a:rPr>
-              <a:t>« T'es vraiment niaiseux de penser que les devoirs servent à rien. »</a:t>
+              <a:t>« T'es vraiment déconnecté si tu penses que le télétravail marche. »</a:t>
             </a:r>
             <a:endParaRPr lang="en-US" sz="1500" dirty="0"/>
           </a:p>
@@ -20385,7 +20664,7 @@
                 <a:ea typeface="Arial" pitchFamily="34" charset="-122"/>
                 <a:cs typeface="Arial" pitchFamily="34" charset="-120"/>
               </a:rPr>
-              <a:t>« Non, les devoirs servent à quelque chose. »</a:t>
+              <a:t>« Non, le télétravail ne marche pas. »</a:t>
             </a:r>
             <a:endParaRPr lang="en-US" sz="1500" dirty="0"/>
           </a:p>
@@ -20483,7 +20762,7 @@
                 <a:ea typeface="Arial" pitchFamily="34" charset="-122"/>
                 <a:cs typeface="Arial" pitchFamily="34" charset="-120"/>
               </a:rPr>
-              <a:t>« Les devoirs permettent de pratiquer à son rythme, loin de la pression de la classe. »</a:t>
+              <a:t>« Le télétravail isole les nouveaux employés : ils apprennent moins vite sans collègues autour. »</a:t>
             </a:r>
             <a:endParaRPr lang="en-US" sz="1500" dirty="0"/>
           </a:p>
@@ -20581,7 +20860,7 @@
                 <a:ea typeface="Arial" pitchFamily="34" charset="-122"/>
                 <a:cs typeface="Arial" pitchFamily="34" charset="-120"/>
               </a:rPr>
-              <a:t>« Tu dis que les devoirs sont inutiles parce qu'ils creusent les écarts. C'est vrai pour certains élèves. Mais si on les rendait facultatifs et soutenus en classe, le problème tomberait-il? »</a:t>
+              <a:t>« Tu dis que le télétravail rend plus productif. C'est vrai pour le travail concentré. Mais si on gardait deux jours sur place pour l'accueil et la collaboration, ton argument tiendrait-il encore? »</a:t>
             </a:r>
             <a:endParaRPr lang="en-US" sz="1300" dirty="0"/>
           </a:p>
@@ -20684,7 +20963,7 @@
                 <a:ea typeface="Arial" pitchFamily="34" charset="-122"/>
                 <a:cs typeface="Arial" pitchFamily="34" charset="-120"/>
               </a:rPr>
-              <a:t>En équipe de 2, choisissez une réplique entendue en ligne ou à l'école. Réécrivez-la aux étages 3, 4 et 6. Lisez l'étage 0 et l'étage 6 à voix haute.</a:t>
+              <a:t>En équipe de 2, choisissez une réplique entendue en ligne, au travail ou en famille. Réécrivez-la aux étages 3, 4 et 6. Lisez l'étage 0 et l'étage 6 à voix haute.</a:t>
             </a:r>
             <a:endParaRPr lang="en-US" sz="1500" dirty="0"/>
           </a:p>
@@ -24862,6 +25141,59 @@
       </p:sp>
       <p:sp>
         <p:nvSpPr>
+          <p:cNvPr id="44" name="Text 42"/>
+          <p:cNvSpPr txBox="1"/>
+          <p:nvPr/>
+        </p:nvSpPr>
+        <p:spPr>
+          <a:xfrm>
+            <a:off x="548640" y="5760720"/>
+            <a:ext cx="11064240" cy="411480"/>
+          </a:xfrm>
+          <a:prstGeom prst="rect">
+            <a:avLst/>
+          </a:prstGeom>
+          <a:noFill/>
+          <a:ln/>
+        </p:spPr>
+        <p:txBody>
+          <a:bodyPr wrap="square" lIns="0" tIns="0" rIns="0" bIns="0" rtlCol="0" anchor="t"/>
+          <a:lstStyle/>
+          <a:p>
+            <a:pPr indent="0" marL="0">
+              <a:buNone/>
+            </a:pPr>
+            <a:r>
+              <a:rPr lang="en-US" sz="1500" b="1" dirty="0">
+                <a:solidFill>
+                  <a:schemeClr val="accent1"/>
+                </a:solidFill>
+                <a:latin typeface="Arial" pitchFamily="34" charset="0"/>
+                <a:ea typeface="Arial" pitchFamily="34" charset="-122"/>
+                <a:cs typeface="Arial" pitchFamily="34" charset="-120"/>
+              </a:rPr>
+              <a:t>Règle du joker : </a:t>
+            </a:r>
+            <a:pPr indent="0" marL="0">
+              <a:buNone/>
+            </a:pPr>
+            <a:r>
+              <a:rPr lang="en-US" sz="1500" dirty="0">
+                <a:solidFill>
+                  <a:schemeClr val="tx1"/>
+                </a:solidFill>
+                <a:latin typeface="Arial" pitchFamily="34" charset="0"/>
+                <a:ea typeface="Arial" pitchFamily="34" charset="-122"/>
+                <a:cs typeface="Arial" pitchFamily="34" charset="-120"/>
+              </a:rPr>
+              <a:t>chacun peut passer son tour, à tout moment, sans se justifier.</a:t>
+            </a:r>
+            <a:endParaRPr lang="en-US" sz="1500" dirty="0"/>
+          </a:p>
+        </p:txBody>
+      </p:sp>
+      <p:sp>
+        <p:nvSpPr>
           <p:cNvPr id="25" name="Slide Number Placeholder 0"/>
           <p:cNvSpPr>
             <a:spLocks noGrp="1"/>
@@ -26580,7 +26912,7 @@
                 <a:ea typeface="Arial" pitchFamily="34" charset="-122"/>
                 <a:cs typeface="Arial" pitchFamily="34" charset="-120"/>
               </a:rPr>
-              <a:t>Sources : A. Schopenhauer, L'Art d'avoir toujours raison · P. Graham, How to Disagree (2008) · D. Dennett, Intuition Pumps (2013) · R. Fisher et W. Ury, Getting to Yes · A. Fluegelman, The New Games Book (1976) · PFEQ, Culture et citoyenneté québécoise</a:t>
+              <a:t>Sources : A. Schopenhauer, L'Art d'avoir toujours raison · P. Graham, How to Disagree (2008) · D. Dennett, Intuition Pumps (2013) · R. Fisher et W. Ury, Getting to Yes · A. Fluegelman, The New Games Book (1976)</a:t>
             </a:r>
             <a:endParaRPr lang="en-US" sz="1100" dirty="0"/>
           </a:p>
@@ -28138,7 +28470,7 @@
                 <a:ea typeface="Arial" pitchFamily="34" charset="-122"/>
                 <a:cs typeface="Arial" pitchFamily="34" charset="-120"/>
               </a:rPr>
-              <a:t>« Les devoirs devraient être abolis. »</a:t>
+              <a:t>« Le télétravail devrait être un droit. »</a:t>
             </a:r>
             <a:endParaRPr lang="en-US" sz="1600" dirty="0"/>
           </a:p>
@@ -28159,7 +28491,7 @@
                 <a:ea typeface="Arial" pitchFamily="34" charset="-122"/>
                 <a:cs typeface="Arial" pitchFamily="34" charset="-120"/>
               </a:rPr>
-              <a:t>« Le cellulaire devrait être permis en classe. »</a:t>
+              <a:t>« On devrait pouvoir parler politique au souper de famille. »</a:t>
             </a:r>
             <a:endParaRPr lang="en-US" sz="1600" dirty="0"/>
           </a:p>

</xml_diff>

<commit_message>
Retire le contenu lié au New Games Book; titre « La confrontation agréable »
Le New Games Book n'inspire plus que le style visuel. Retrait du titre
« Le nouveau livre du débat », de la devise dérivée et des références au
livre. Nouvelle devise : dur sur les idées, doux avec les gens.

Co-Authored-By: Claude Opus 5.5 <noreply@anthropic.com>
Claude-Session: https://claude.ai/code/session_01CA8BLVt7gkumiP2uBqg34x
</commit_message>
<xml_diff>
--- a/debat-agreable/seminaire-confrontation-agreable.pptx
+++ b/debat-agreable/seminaire-confrontation-agreable.pptx
@@ -141,14 +141,14 @@
   <p:extLst>
     <p:ext uri="{521415D9-36F7-43E2-AB2F-B90AF26B5E84}">
       <p14:sectionLst xmlns:p14="http://schemas.microsoft.com/office/powerpoint/2010/main">
-        <p14:section name="Ouverture" id="{df4fb7b1-2838-11d1-83ea-1643ee95c009}">
+        <p14:section name="Ouverture" id="{7ab7b596-213d-6b9d-f6cf-b6ea309a7306}">
           <p14:sldIdLst>
             <p14:sldId id="256"/>
             <p14:sldId id="257"/>
             <p14:sldId id="258"/>
           </p14:sldIdLst>
         </p14:section>
-        <p14:section name="Échauffement" id="{5b8498b8-749f-c47b-cc72-f633c4db99a4}">
+        <p14:section name="Échauffement" id="{83cb0293-c704-9cdf-383e-076951008eb9}">
           <p14:sldIdLst>
             <p14:sldId id="259"/>
             <p14:sldId id="260"/>
@@ -156,7 +156,7 @@
             <p14:sldId id="262"/>
           </p14:sldIdLst>
         </p14:section>
-        <p14:section name="Le manuel du tricheur" id="{6f15ba69-7c77-a6c9-da0b-e4d0233fa1c5}">
+        <p14:section name="Le manuel du tricheur" id="{bff9139a-7af8-f24f-8193-88aa88894c65}">
           <p14:sldIdLst>
             <p14:sldId id="263"/>
             <p14:sldId id="264"/>
@@ -167,7 +167,7 @@
             <p14:sldId id="269"/>
           </p14:sldIdLst>
         </p14:section>
-        <p14:section name="Le bestiaire" id="{9c877d8d-71d8-571b-b0f1-310a62f2a9c5}">
+        <p14:section name="Le bestiaire" id="{3f2f33f3-d135-0528-fe01-a2d8f1b88124}">
           <p14:sldIdLst>
             <p14:sldId id="270"/>
             <p14:sldId id="271"/>
@@ -176,7 +176,7 @@
             <p14:sldId id="274"/>
           </p14:sldIdLst>
         </p14:section>
-        <p14:section name="Ateliers d'écriture" id="{c12c0a07-ead7-e903-684a-c9fe37d86713}">
+        <p14:section name="Ateliers d'écriture" id="{bdb6a10e-0b75-2149-1e69-939b1d5b23b4}">
           <p14:sldIdLst>
             <p14:sldId id="275"/>
             <p14:sldId id="276"/>
@@ -184,14 +184,14 @@
             <p14:sldId id="278"/>
           </p14:sldIdLst>
         </p14:section>
-        <p14:section name="L'arène agréable" id="{e8be822e-e702-ba08-0fb4-04005561b17b}">
+        <p14:section name="L'arène agréable" id="{4cb2839f-47af-f184-b8d0-385691e09d8b}">
           <p14:sldIdLst>
             <p14:sldId id="279"/>
             <p14:sldId id="280"/>
             <p14:sldId id="281"/>
           </p14:sldIdLst>
         </p14:section>
-        <p14:section name="Repartir avec" id="{052469de-c01d-398c-d89c-4e73aae9eca1}">
+        <p14:section name="Repartir avec" id="{32c88d44-d2a7-84ff-1fdb-8a67523acab0}">
           <p14:sldIdLst>
             <p14:sldId id="282"/>
             <p14:sldId id="283"/>
@@ -200,7 +200,7 @@
             <p14:sldId id="286"/>
           </p14:sldIdLst>
         </p14:section>
-        <p14:section name="Annexes" id="{0ceb8008-8aab-958d-6421-51ec0a44a6e1}">
+        <p14:section name="Annexes" id="{f9b60df0-b8dd-5385-90c4-1d62505117b5}">
           <p14:sldIdLst>
             <p14:sldId id="287"/>
             <p14:sldId id="288"/>
@@ -612,7 +612,7 @@
           <a:p>
             <a:r>
               <a:rPr lang="en-US" dirty="0"/>
-              <a:t>Accueil. Le visuel s'inspire du New Games Book (1976) : « Play hard, play fair, nobody hurt ». Notre pari : transposer cette éthique du jeu coopératif au débat. On va apprendre les coups bas de Schopenhauer pour les reconnaître, puis pratiquer un débat ferme ET agréable. Durée totale : environ 3 h.</a:t>
+              <a:t>Accueil. Notre pari : apprendre les coups bas de Schopenhauer pour les reconnaître, puis pratiquer un débat ferme ET agréable : dur sur les idées, doux avec les gens. Durée totale : environ 3 h.</a:t>
             </a:r>
             <a:endParaRPr lang="en-US" dirty="0"/>
           </a:p>
@@ -2724,7 +2724,7 @@
           <a:p>
             <a:r>
               <a:rPr lang="en-US" dirty="0"/>
-              <a:t>Clôture. Remettre la devise du New Games Book transposée au débat. Inviter les participants à repartir avec leur zine, leur talisman et, peut-être, une mise à jour envoyée.</a:t>
+              <a:t>Clôture. Rappeler la devise : dur sur les idées, doux avec les gens. Inviter les participants à repartir avec leur zine, leur talisman et, peut-être, une mise à jour envoyée.</a:t>
             </a:r>
             <a:endParaRPr lang="en-US" dirty="0"/>
           </a:p>
@@ -4007,7 +4007,7 @@
                 <a:ea typeface="Arial" pitchFamily="34" charset="-122"/>
                 <a:cs typeface="Arial" pitchFamily="34" charset="-120"/>
               </a:rPr>
-              <a:t>LE NOUVEAU LIVRE DU DÉBAT</a:t>
+              <a:t>LA CONFRONTATION AGRÉABLE</a:t>
             </a:r>
             <a:endParaRPr lang="en-US" sz="900" dirty="0"/>
           </a:p>
@@ -4567,7 +4567,7 @@
                 <a:ea typeface="Arial" pitchFamily="34" charset="-122"/>
                 <a:cs typeface="Arial" pitchFamily="34" charset="-120"/>
               </a:rPr>
-              <a:t>SÉMINAIRE · LA CONFRONTATION AGRÉABLE</a:t>
+              <a:t>SÉMINAIRE · 3 H · ADULTES CURIEUX</a:t>
             </a:r>
             <a:endParaRPr lang="en-US" sz="1400" dirty="0"/>
           </a:p>
@@ -4608,7 +4608,7 @@
                   <a:schemeClr val="accent1"/>
                 </a:solidFill>
               </a:rPr>
-              <a:t>LE NOUVEAU</a:t>
+              <a:t>LA</a:t>
             </a:r>
             <a:endParaRPr lang="en-US" sz="6600" dirty="0"/>
           </a:p>
@@ -4625,7 +4625,7 @@
                   <a:schemeClr val="accent1"/>
                 </a:solidFill>
               </a:rPr>
-              <a:t>LIVRE DU</a:t>
+              <a:t>CONFRON-</a:t>
             </a:r>
             <a:endParaRPr lang="en-US" sz="6600" dirty="0"/>
           </a:p>
@@ -4642,7 +4642,24 @@
                   <a:schemeClr val="accent1"/>
                 </a:solidFill>
               </a:rPr>
-              <a:t>DÉBAT</a:t>
+              <a:t>TATION</a:t>
+            </a:r>
+            <a:endParaRPr lang="en-US" sz="6600" dirty="0"/>
+          </a:p>
+          <a:p>
+            <a:pPr algn="l" indent="0" marL="0">
+              <a:lnSpc>
+                <a:spcPct val="85000"/>
+              </a:lnSpc>
+              <a:buNone/>
+            </a:pPr>
+            <a:r>
+              <a:rPr lang="en-US" sz="6600" dirty="0">
+                <a:solidFill>
+                  <a:schemeClr val="accent1"/>
+                </a:solidFill>
+              </a:rPr>
+              <a:t>AGRÉABLE</a:t>
             </a:r>
             <a:endParaRPr lang="en-US" sz="6600" dirty="0"/>
           </a:p>
@@ -4705,7 +4722,7 @@
                 <a:ea typeface="Arial" pitchFamily="34" charset="-122"/>
                 <a:cs typeface="Arial" pitchFamily="34" charset="-120"/>
               </a:rPr>
-              <a:t>Débattre fort</a:t>
+              <a:t>Dur sur les idées.</a:t>
             </a:r>
             <a:endParaRPr lang="en-US" sz="1800" dirty="0"/>
           </a:p>
@@ -4722,24 +4739,7 @@
                 <a:ea typeface="Arial" pitchFamily="34" charset="-122"/>
                 <a:cs typeface="Arial" pitchFamily="34" charset="-120"/>
               </a:rPr>
-              <a:t>Débattre juste</a:t>
-            </a:r>
-            <a:endParaRPr lang="en-US" sz="1800" dirty="0"/>
-          </a:p>
-          <a:p>
-            <a:pPr algn="l" indent="0" marL="0">
-              <a:buNone/>
-            </a:pPr>
-            <a:r>
-              <a:rPr lang="en-US" sz="1800" b="1" dirty="0">
-                <a:solidFill>
-                  <a:schemeClr val="tx1"/>
-                </a:solidFill>
-                <a:latin typeface="Arial" pitchFamily="34" charset="0"/>
-                <a:ea typeface="Arial" pitchFamily="34" charset="-122"/>
-                <a:cs typeface="Arial" pitchFamily="34" charset="-120"/>
-              </a:rPr>
-              <a:t>Personne blessé·e</a:t>
+              <a:t>Doux avec les gens.</a:t>
             </a:r>
             <a:endParaRPr lang="en-US" sz="1800" dirty="0"/>
           </a:p>
@@ -24076,7 +24076,7 @@
                   <a:schemeClr val="accent1"/>
                 </a:solidFill>
               </a:rPr>
-              <a:t>Débattre fort.</a:t>
+              <a:t>Dur sur</a:t>
             </a:r>
             <a:endParaRPr lang="en-US" sz="6600" dirty="0"/>
           </a:p>
@@ -24093,7 +24093,7 @@
                   <a:schemeClr val="accent1"/>
                 </a:solidFill>
               </a:rPr>
-              <a:t>Débattre juste.</a:t>
+              <a:t>les idées.</a:t>
             </a:r>
             <a:endParaRPr lang="en-US" sz="6600" dirty="0"/>
           </a:p>
@@ -24110,7 +24110,24 @@
                   <a:schemeClr val="accent1"/>
                 </a:solidFill>
               </a:rPr>
-              <a:t>Personne blessé·e.</a:t>
+              <a:t>Doux avec</a:t>
+            </a:r>
+            <a:endParaRPr lang="en-US" sz="6600" dirty="0"/>
+          </a:p>
+          <a:p>
+            <a:pPr algn="l" indent="0" marL="0">
+              <a:lnSpc>
+                <a:spcPct val="85000"/>
+              </a:lnSpc>
+              <a:buNone/>
+            </a:pPr>
+            <a:r>
+              <a:rPr lang="en-US" sz="6600" dirty="0">
+                <a:solidFill>
+                  <a:schemeClr val="accent1"/>
+                </a:solidFill>
+              </a:rPr>
+              <a:t>les gens.</a:t>
             </a:r>
             <a:endParaRPr lang="en-US" sz="6600" dirty="0"/>
           </a:p>
@@ -24236,7 +24253,7 @@
                 <a:ea typeface="Arial" pitchFamily="34" charset="-122"/>
                 <a:cs typeface="Arial" pitchFamily="34" charset="-120"/>
               </a:rPr>
-              <a:t>Sources : A. Schopenhauer, L'Art d'avoir toujours raison · P. Graham, How to Disagree (2008) · D. Dennett, Intuition Pumps (2013) · R. Fisher et W. Ury, Getting to Yes · A. Fluegelman, The New Games Book (1976)</a:t>
+              <a:t>Sources : A. Schopenhauer, L'Art d'avoir toujours raison · P. Graham, How to Disagree (2008) · D. Dennett, Intuition Pumps (2013) · R. Fisher et W. Ury, Getting to Yes</a:t>
             </a:r>
             <a:endParaRPr lang="en-US" sz="1100" dirty="0"/>
           </a:p>
@@ -33159,9 +33176,9 @@
 </file>
 
 <file path=ppt/theme/theme1.xml><?xml version="1.0" encoding="utf-8"?>
-<a:theme xmlns:a="http://schemas.openxmlformats.org/drawingml/2006/main" name="Nouveau livre du debat">
+<a:theme xmlns:a="http://schemas.openxmlformats.org/drawingml/2006/main" name="Confrontation agreable">
   <a:themeElements>
-    <a:clrScheme name="Nouveau livre du debat">
+    <a:clrScheme name="Confrontation agreable">
       <a:dk1>
         <a:srgbClr val="1B1714"/>
       </a:dk1>
@@ -33199,7 +33216,7 @@
         <a:srgbClr val="6B4B10"/>
       </a:folHlink>
     </a:clrScheme>
-    <a:fontScheme name="Nouveau livre du debat">
+    <a:fontScheme name="Confrontation agreable">
       <a:majorFont>
         <a:latin typeface="Rockwell Extra Bold"/>
         <a:ea typeface=""/>

</xml_diff>